<commit_message>
Multi-dataset extension, verification kit, 5.36 m flow document
Add five datasets, V2 deck/report builders, and report/HUIM_IPS_flow_5.36m.html
(step-by-step flow plus per-building analysis). Remove duplicate dataset zip.

Co-Authored-By: Claude Sonnet 5.5 <noreply@anthropic.com>
</commit_message>
<xml_diff>
--- a/slides/HUIM_IPS_UJIIndoorLoc_Presentation.pptx
+++ b/slides/HUIM_IPS_UJIIndoorLoc_Presentation.pptx
@@ -25,6 +25,7 @@
     <p:sldId id="273" r:id="rId25"/>
     <p:sldId id="274" r:id="rId26"/>
     <p:sldId id="275" r:id="rId27"/>
+    <p:sldId id="276" r:id="rId28"/>
   </p:sldIdLst>
   <p:sldSz cx="12191695" cy="6858000" type="screen4x3"/>
   <p:notesSz cx="6858000" cy="9144000"/>
@@ -849,19 +850,19 @@
           <a:lstStyle/>
           <a:p>
             <a:r>
-              <a:t>Tôi cần nói gì: Đây là tiêu chí thứ hai nhóm đặt ra. Chi phí khai thác HUIM đã nói ở slide trước; slide này là chi phí của chính hệ thống định vị.</a:t>
+              <a:t>Tôi cần nói gì: k-NN của nghiên cứu (k=1, Manhattan) được chọn cho bài toán phân loại tầng trên một phép chia ngẫu nhiên, nên không phải bộ ước lượng toạ độ tốt. Em tối ưu riêng phần ước lượng toạ độ.</a:t>
             </a:r>
           </a:p>
           <a:p/>
           <a:p>
             <a:r>
-              <a:t>Thông điệp chính: Giảm chiều cho lợi ích tuyến tính và rất rõ về cả thời gian lẫn bộ nhớ — nhưng tập đặc trưng tốt nhất đến từ đối chứng đơn giản, không phải từ HUIM.</a:t>
+              <a:t>Thông điệp chính: mọi lựa chọn được làm trên các fold giữ lại người đo của trainingData; validationData chỉ chấm điểm mỗi bước đúng một lần.</a:t>
             </a:r>
           </a:p>
           <a:p/>
           <a:p>
             <a:r>
-              <a:t>Nếu cô hỏi sâu: Em đo với n_jobs=1 để con số là chi phí một lõi, khả chuyển. Ở số chiều nhỏ nhất đường cong không đơn điệu vì scikit-learn chuyển sang chỉ mục kd_tree, mà trên dữ liệu thưa thì cây chậm hơn duyệt vét cạn — em có ghi lại thuật toán index trong log để chứng minh.</a:t>
+              <a:t>Nếu cô hỏi sâu: bước dò độ lệch thiết bị và ensemble thắng trên dev nhưng không thắng trên validation về sai số mét — em vẫn giữ mô hình mà giao thức chọn, vì chọn lại theo validation là dùng tập kiểm tra để chọn mô hình. Mọi con số kiểm chứng được trong verification/kiem_chung_thu_cong.xlsx.</a:t>
             </a:r>
           </a:p>
         </p:txBody>
@@ -931,19 +932,19 @@
           <a:lstStyle/>
           <a:p>
             <a:r>
-              <a:t>Tôi cần nói gì: Đọc ba cột của baseline, rồi so với HUIM tốt nhất. Nhấn rằng Building gần như được giải quyết còn Floor là phần khó.</a:t>
+              <a:t>Tôi cần nói gì: Đây là tiêu chí thứ hai nhóm đặt ra. Chi phí khai thác HUIM đã nói ở slide trước; slide này là chi phí của chính hệ thống định vị.</a:t>
             </a:r>
           </a:p>
           <a:p/>
           <a:p>
             <a:r>
-              <a:t>Thông điệp chính: Một báo cáo chỉ nêu Building accuracy sẽ làm phương pháp trông tốt hơn thực tế rất nhiều.</a:t>
+              <a:t>Thông điệp chính: Giảm chiều cho lợi ích tuyến tính và rất rõ về cả thời gian lẫn bộ nhớ — nhưng tập đặc trưng tốt nhất đến từ đối chứng đơn giản, không phải từ HUIM.</a:t>
             </a:r>
           </a:p>
           <a:p/>
           <a:p>
             <a:r>
-              <a:t>Nếu cô hỏi sâu: Cả ba accuracy suy ra từ CÙNG một dự đoán nhãn joint, nên chúng nhất quán theo cấu trúc — mô hình không thể được ghi công 'đúng tầng' khi nó dự đoán sai toà nhà.</a:t>
+              <a:t>Nếu cô hỏi sâu: Em đo với n_jobs=1 để con số là chi phí một lõi, khả chuyển. Ở số chiều nhỏ nhất đường cong không đơn điệu vì scikit-learn chuyển sang chỉ mục kd_tree, mà trên dữ liệu thưa thì cây chậm hơn duyệt vét cạn — em có ghi lại thuật toán index trong log để chứng minh.</a:t>
             </a:r>
           </a:p>
         </p:txBody>
@@ -1013,19 +1014,19 @@
           <a:lstStyle/>
           <a:p>
             <a:r>
-              <a:t>Tôi cần nói gì: Ablation không chỉ so HUIM với 'dùng tất cả'. Phải có đối chứng ở CÙNG ngân sách đặc trưng, nếu không thì không phân biệt được CHỌN đặc trưng với XOÁ đặc trưng.</a:t>
+              <a:t>Tôi cần nói gì: Đọc ba cột của baseline, rồi so với HUIM tốt nhất. Nhấn rằng Building gần như được giải quyết còn Floor là phần khó.</a:t>
             </a:r>
           </a:p>
           <a:p/>
           <a:p>
             <a:r>
-              <a:t>Thông điệp chính: Ba đối chứng trả lời ba câu khác nhau, và chỉ câu thứ ba là về HUIM.</a:t>
+              <a:t>Thông điệp chính: Một báo cáo chỉ nêu Building accuracy sẽ làm phương pháp trông tốt hơn thực tế rất nhiều.</a:t>
             </a:r>
           </a:p>
           <a:p/>
           <a:p>
             <a:r>
-              <a:t>Nếu cô hỏi sâu: Nếu HUIM không vượt top-n theo MI thì đó là kết quả ÂM và em báo cáo đúng như vậy — giá trị nằm ở chỗ đã thiết lập được phép so sánh đó.</a:t>
+              <a:t>Nếu cô hỏi sâu: Cả ba accuracy suy ra từ CÙNG một dự đoán nhãn joint, nên chúng nhất quán theo cấu trúc — mô hình không thể được ghi công 'đúng tầng' khi nó dự đoán sai toà nhà.</a:t>
             </a:r>
           </a:p>
         </p:txBody>
@@ -1095,19 +1096,19 @@
           <a:lstStyle/>
           <a:p>
             <a:r>
-              <a:t>Tôi cần nói gì: Đây là slide trả lời RQ4-RQ6. Đi từ phải sang: giảm chiều tăng thì accuracy đi về đâu. So HUIM với ba đường đối chứng.</a:t>
+              <a:t>Tôi cần nói gì: Ablation không chỉ so HUIM với 'dùng tất cả'. Phải có đối chứng ở CÙNG ngân sách đặc trưng, nếu không thì không phân biệt được CHỌN đặc trưng với XOÁ đặc trưng.</a:t>
             </a:r>
           </a:p>
           <a:p/>
           <a:p>
             <a:r>
-              <a:t>Thông điệp chính: Câu trả lời cho 'giảm được bao nhiêu WAP' không phải một con số — nó phụ thuộc vào accuracy nào đang được bảo vệ.</a:t>
+              <a:t>Thông điệp chính: Ba đối chứng trả lời ba câu khác nhau, và chỉ câu thứ ba là về HUIM.</a:t>
             </a:r>
           </a:p>
           <a:p/>
           <a:p>
             <a:r>
-              <a:t>Nếu cô hỏi sâu: Em KHÔNG gọi đây là Pareto front, vì chưa kiểm tra điều kiện Pareto một cách hình thức. Em chỉ nói có trade-off. Ở ngân sách nhỏ, một phần sụt giảm là do MẤT ĐỘ PHỦ chứ không phải mất khả năng phân biệt — em log riêng số fingerprint kiểm định không phát hiện được AP nào trong tập đã chọn.</a:t>
+              <a:t>Nếu cô hỏi sâu: Nếu HUIM không vượt top-n theo MI thì đó là kết quả ÂM và em báo cáo đúng như vậy — giá trị nằm ở chỗ đã thiết lập được phép so sánh đó.</a:t>
             </a:r>
           </a:p>
         </p:txBody>
@@ -1177,19 +1178,19 @@
           <a:lstStyle/>
           <a:p>
             <a:r>
-              <a:t>Tôi cần nói gì: Đi dọc chuỗi ở giữa, từ trên xuống: hành vi quan sát được → cơ chế bùng nổ → vai trò của chặn trên → lý thuyết (utility không có downward closure) → ý nghĩa cho IPS.</a:t>
+              <a:t>Tôi cần nói gì: Đây là slide trả lời RQ4-RQ6. Đi từ phải sang: giảm chiều tăng thì accuracy đi về đâu. So HUIM với ba đường đối chứng.</a:t>
             </a:r>
           </a:p>
           <a:p/>
           <a:p>
             <a:r>
-              <a:t>Thông điệp chính: Đây là cách em học được lý thuyết — từ hiện tượng, không từ định nghĩa.</a:t>
+              <a:t>Thông điệp chính: Câu trả lời cho 'giảm được bao nhiêu WAP' không phải một con số — nó phụ thuộc vào accuracy nào đang được bảo vệ.</a:t>
             </a:r>
           </a:p>
           <a:p/>
           <a:p>
             <a:r>
-              <a:t>Nếu cô hỏi sâu: Các con số trong chuỗi lấy đúng từ log, và phân tích đầy đủ 8 quan sát nằm trong research/reverse_thinking_analysis.md — file đó và chương 15 của báo cáo Word đọc cùng một file JSON nên không thể lệch nhau.</a:t>
+              <a:t>Nếu cô hỏi sâu: Em KHÔNG gọi đây là Pareto front, vì chưa kiểm tra điều kiện Pareto một cách hình thức. Em chỉ nói có trade-off. Ở ngân sách nhỏ, một phần sụt giảm là do MẤT ĐỘ PHỦ chứ không phải mất khả năng phân biệt — em log riêng số fingerprint kiểm định không phát hiện được AP nào trong tập đã chọn.</a:t>
             </a:r>
           </a:p>
         </p:txBody>
@@ -1259,19 +1260,19 @@
           <a:lstStyle/>
           <a:p>
             <a:r>
-              <a:t>Tôi cần nói gì: Cột trái chỉ ghi điều số liệu chứng minh. Cột phải ghi điều em KHÔNG khẳng định.</a:t>
+              <a:t>Tôi cần nói gì: Đi dọc chuỗi ở giữa, từ trên xuống: hành vi quan sát được → cơ chế bùng nổ → vai trò của chặn trên → lý thuyết (utility không có downward closure) → ý nghĩa cho IPS.</a:t>
             </a:r>
           </a:p>
           <a:p/>
           <a:p>
             <a:r>
-              <a:t>Thông điệp chính: Giới hạn của kết luận là một phần của kết luận.</a:t>
+              <a:t>Thông điệp chính: Đây là cách em học được lý thuyết — từ hiện tượng, không từ định nghĩa.</a:t>
             </a:r>
           </a:p>
           <a:p/>
           <a:p>
             <a:r>
-              <a:t>Nếu cô hỏi sâu: Điểm quan trọng nhất ở cột phải là dòng cuối — HUIM là bài toán không giám sát, không có gì trong định nghĩa của nó tối ưu một mục tiêu phân loại. Vì vậy không có định lý nào để viện dẫn, chỉ có số liệu đối chứng.</a:t>
+              <a:t>Nếu cô hỏi sâu: Các con số trong chuỗi lấy đúng từ log, và phân tích đầy đủ 8 quan sát nằm trong research/reverse_thinking_analysis.md — file đó và chương 15 của báo cáo Word đọc cùng một file JSON nên không thể lệch nhau.</a:t>
             </a:r>
           </a:p>
         </p:txBody>
@@ -1341,19 +1342,19 @@
           <a:lstStyle/>
           <a:p>
             <a:r>
-              <a:t>Tôi cần nói gì: Trả lời trực tiếp từng câu hỏi nghiên cứu bằng con số. Không dùng từ 'vượt trội'.</a:t>
+              <a:t>Tôi cần nói gì: Cột trái chỉ ghi điều số liệu chứng minh. Cột phải ghi điều em KHÔNG khẳng định.</a:t>
             </a:r>
           </a:p>
           <a:p/>
           <a:p>
             <a:r>
-              <a:t>Thông điệp chính: Trade-off chính nằm ngược trực giác — ngưỡng cao tốt hơn ngưỡng thấp cho mục đích chọn AP.</a:t>
+              <a:t>Thông điệp chính: Giới hạn của kết luận là một phần của kết luận.</a:t>
             </a:r>
           </a:p>
           <a:p/>
           <a:p>
             <a:r>
-              <a:t>Nếu cô hỏi sâu: Nếu cô hỏi 'vậy có nên dùng HUIM cho IPS không', câu trả lời trung thực là: dựa trên thực nghiệm này, HUIM là một cách hợp lệ để chọn nhóm AP nhưng chưa chứng minh được là tốt hơn các tiêu chí information-theoretic đơn giản hơn — và bảng đối chứng ngân sách khớp nhau là bằng chứng duy nhất em đưa ra.</a:t>
+              <a:t>Nếu cô hỏi sâu: Điểm quan trọng nhất ở cột phải là dòng cuối — HUIM là bài toán không giám sát, không có gì trong định nghĩa của nó tối ưu một mục tiêu phân loại. Vì vậy không có định lý nào để viện dẫn, chỉ có số liệu đối chứng.</a:t>
             </a:r>
           </a:p>
         </p:txBody>
@@ -1461,6 +1462,88 @@
 </file>
 
 <file path=ppt/notesSlides/notesSlide20.xml><?xml version="1.0" encoding="utf-8"?>
+<p:notes xmlns:a="http://schemas.openxmlformats.org/drawingml/2006/main" xmlns:p="http://schemas.openxmlformats.org/presentationml/2006/main" xmlns:r="http://schemas.openxmlformats.org/officeDocument/2006/relationships">
+  <p:cSld>
+    <p:spTree>
+      <p:nvGrpSpPr>
+        <p:cNvPr id="1" name=""/>
+        <p:cNvGrpSpPr/>
+        <p:nvPr/>
+      </p:nvGrpSpPr>
+      <p:grpSpPr>
+        <a:xfrm>
+          <a:off x="0" y="0"/>
+          <a:ext cx="0" cy="0"/>
+          <a:chOff x="0" y="0"/>
+          <a:chExt cx="0" cy="0"/>
+        </a:xfrm>
+      </p:grpSpPr>
+      <p:sp>
+        <p:nvSpPr>
+          <p:cNvPr id="2" name="Slide Image Placeholder 1"/>
+          <p:cNvSpPr>
+            <a:spLocks noGrp="1"/>
+          </p:cNvSpPr>
+          <p:nvPr>
+            <p:ph type="sldImg" idx="2"/>
+          </p:nvPr>
+        </p:nvSpPr>
+        <p:spPr/>
+      </p:sp>
+      <p:sp>
+        <p:nvSpPr>
+          <p:cNvPr id="3" name="Notes Placeholder 2"/>
+          <p:cNvSpPr>
+            <a:spLocks noGrp="1"/>
+          </p:cNvSpPr>
+          <p:nvPr>
+            <p:ph type="body" idx="3" sz="quarter"/>
+          </p:nvPr>
+        </p:nvSpPr>
+        <p:spPr/>
+        <p:txBody>
+          <a:bodyPr/>
+          <a:lstStyle/>
+          <a:p>
+            <a:r>
+              <a:t>Tôi cần nói gì: Trả lời trực tiếp từng câu hỏi nghiên cứu bằng con số. Không dùng từ 'vượt trội'.</a:t>
+            </a:r>
+          </a:p>
+          <a:p/>
+          <a:p>
+            <a:r>
+              <a:t>Thông điệp chính: Trade-off chính nằm ngược trực giác — ngưỡng cao tốt hơn ngưỡng thấp cho mục đích chọn AP.</a:t>
+            </a:r>
+          </a:p>
+          <a:p/>
+          <a:p>
+            <a:r>
+              <a:t>Nếu cô hỏi sâu: Nếu cô hỏi 'vậy có nên dùng HUIM cho IPS không', câu trả lời trung thực là: dựa trên thực nghiệm này, HUIM là một cách hợp lệ để chọn nhóm AP nhưng chưa chứng minh được là tốt hơn các tiêu chí information-theoretic đơn giản hơn — và bảng đối chứng ngân sách khớp nhau là bằng chứng duy nhất em đưa ra.</a:t>
+            </a:r>
+          </a:p>
+        </p:txBody>
+      </p:sp>
+      <p:sp>
+        <p:nvSpPr>
+          <p:cNvPr id="4" name="Slide Number Placeholder 3"/>
+          <p:cNvSpPr>
+            <a:spLocks noGrp="1"/>
+          </p:cNvSpPr>
+          <p:nvPr>
+            <p:ph type="sldNum" idx="5" sz="quarter"/>
+          </p:nvPr>
+        </p:nvSpPr>
+        <p:spPr/>
+      </p:sp>
+    </p:spTree>
+  </p:cSld>
+  <p:clrMapOvr>
+    <a:masterClrMapping/>
+  </p:clrMapOvr>
+</p:notes>
+</file>
+
+<file path=ppt/notesSlides/notesSlide21.xml><?xml version="1.0" encoding="utf-8"?>
 <p:notes xmlns:a="http://schemas.openxmlformats.org/drawingml/2006/main" xmlns:p="http://schemas.openxmlformats.org/presentationml/2006/main" xmlns:r="http://schemas.openxmlformats.org/officeDocument/2006/relationships">
   <p:cSld>
     <p:spTree>
@@ -6147,8 +6230,8 @@
         </p:blipFill>
         <p:spPr>
           <a:xfrm>
-            <a:off x="2788920" y="1554480"/>
-            <a:ext cx="6583679" cy="3291839"/>
+            <a:off x="2446386" y="1554480"/>
+            <a:ext cx="7268747" cy="3291839"/>
           </a:xfrm>
           <a:prstGeom prst="rect">
             <a:avLst/>
@@ -6216,6 +6299,27 @@
                 <a:cs typeface="Times New Roman"/>
               </a:rPr>
               <a:t>–  Trung vị DƯỚI dải 7–8 m; trung bình TRÊN dải, vì phân bố có đuôi dài (p95 = 27.8 m).</a:t>
+            </a:r>
+          </a:p>
+          <a:p>
+            <a:pPr algn="l">
+              <a:lnSpc>
+                <a:spcPct val="112000"/>
+              </a:lnSpc>
+              <a:spcAft>
+                <a:spcPts val="700"/>
+              </a:spcAft>
+            </a:pPr>
+            <a:r>
+              <a:rPr sz="1300" b="0" i="0">
+                <a:solidFill>
+                  <a:srgbClr val="1A1A1A"/>
+                </a:solidFill>
+                <a:latin typeface="Times New Roman"/>
+                <a:ea typeface="Times New Roman"/>
+                <a:cs typeface="Times New Roman"/>
+              </a:rPr>
+              <a:t>–  Mô hình tối ưu (nhóm tô nền): trung bình 5.36 m, trung vị 3.52 m thực địa — cả hai DƯỚI dải 7–8 m (toạ độ chiếu: trung bình 6.99 m); 80.5% fingerprint sai số ≤ 8 m, p90 = 11.9 m.</a:t>
             </a:r>
           </a:p>
           <a:p>
@@ -6319,7 +6423,7 @@
                 <a:ea typeface="Times New Roman"/>
                 <a:cs typeface="Times New Roman"/>
               </a:rPr>
-              <a:t>Đánh giá thời gian và bộ nhớ</a:t>
+              <a:t>Tối ưu sai số định vị theo mét</a:t>
             </a:r>
           </a:p>
         </p:txBody>
@@ -6363,7 +6467,7 @@
                 <a:ea typeface="Times New Roman"/>
                 <a:cs typeface="Times New Roman"/>
               </a:rPr>
-              <a:t>Phía hệ thống định vị — nơi giảm chiều thực sự trả công</a:t>
+              <a:t>Chọn trên fold 'giữ lại người đo' của trainingData; validationData chỉ để đánh giá</a:t>
             </a:r>
           </a:p>
         </p:txBody>
@@ -6414,7 +6518,7 @@
       </p:sp>
       <p:pic>
         <p:nvPicPr>
-          <p:cNvPr id="5" name="Picture 4" descr="fig16_ips_time_and_memory.png"/>
+          <p:cNvPr id="5" name="Picture 4" descr="fig18_positioning_optimisation.png"/>
           <p:cNvPicPr>
             <a:picLocks noChangeAspect="1"/>
           </p:cNvPicPr>
@@ -6428,8 +6532,8 @@
         </p:blipFill>
         <p:spPr>
           <a:xfrm>
-            <a:off x="1674080" y="1581912"/>
-            <a:ext cx="8813358" cy="3172968"/>
+            <a:off x="2155983" y="1554480"/>
+            <a:ext cx="7849552" cy="3063239"/>
           </a:xfrm>
           <a:prstGeom prst="rect">
             <a:avLst/>
@@ -6444,8 +6548,8 @@
         </p:nvSpPr>
         <p:spPr>
           <a:xfrm>
-            <a:off x="502920" y="4864608"/>
-            <a:ext cx="11201400" cy="1856231"/>
+            <a:off x="502920" y="4709158"/>
+            <a:ext cx="11201400" cy="2011681"/>
           </a:xfrm>
           <a:prstGeom prst="rect">
             <a:avLst/>
@@ -6475,7 +6579,7 @@
                 <a:ea typeface="Times New Roman"/>
                 <a:cs typeface="Times New Roman"/>
               </a:rPr>
-              <a:t>–  Baseline 520 WAP: 1.207 ms/fingerprint, CSDL vân tay 79.1 MB.</a:t>
+              <a:t>–  Sai số trung bình 9.28 m → 5.36 m thực địa (-42%); trung vị 4.61 → 3.52 m; joint accuracy 87.76% → 94.69%.</a:t>
             </a:r>
           </a:p>
           <a:p>
@@ -6496,7 +6600,7 @@
                 <a:ea typeface="Times New Roman"/>
                 <a:cs typeface="Times New Roman"/>
               </a:rPr>
-              <a:t>–  control_top_support__n200 (200 WAP): 0.491 ms/fp (2.5× nhanh hơn), 38% bộ nhớ, và joint accuracy 88.48% (+0.72 pp).</a:t>
+              <a:t>–  Mô hình được chọn: exponential+braycurtis, k=12, w=1/d^4, offset +-6 dB, ensemble with positive.</a:t>
             </a:r>
           </a:p>
           <a:p>
@@ -6517,7 +6621,7 @@
                 <a:ea typeface="Times New Roman"/>
                 <a:cs typeface="Times New Roman"/>
               </a:rPr>
-              <a:t>–  HUIM tốt nhất (91 WAP): 5.4× nhanh hơn, 18% bộ nhớ, nhưng accuracy 71.56%.</a:t>
+              <a:t>–  Cải thiện chủ yếu nhờ khoảng cách Bray-Curtis và k láng giềng có trọng số; dò độ lệch thiết bị và ensemble chỉ nâng độ chính xác tầng, không giảm thêm sai số mét trên validation.</a:t>
             </a:r>
           </a:p>
           <a:p>
@@ -6538,7 +6642,7 @@
                 <a:ea typeface="Times New Roman"/>
                 <a:cs typeface="Times New Roman"/>
               </a:rPr>
-              <a:t>–  Đo một lõi, lặp lại lấy trung vị; bộ nhớ CSDL tính chính xác (dòng × cột × kích thước phần tử), không ước lượng.</a:t>
+              <a:t>–  Tập WAP của HUIM cũng giảm sai số nhưng vẫn xa dải 7–8 m: kết luận về HUIM không đổi.</a:t>
             </a:r>
           </a:p>
         </p:txBody>
@@ -6600,7 +6704,7 @@
                 <a:ea typeface="Times New Roman"/>
                 <a:cs typeface="Times New Roman"/>
               </a:rPr>
-              <a:t>Baseline so với HUIM</a:t>
+              <a:t>Đánh giá thời gian và bộ nhớ</a:t>
             </a:r>
           </a:p>
         </p:txBody>
@@ -6644,7 +6748,7 @@
                 <a:ea typeface="Times New Roman"/>
                 <a:cs typeface="Times New Roman"/>
               </a:rPr>
-              <a:t>Building / Floor / Joint accuracy</a:t>
+              <a:t>Phía hệ thống định vị — nơi giảm chiều thực sự trả công</a:t>
             </a:r>
           </a:p>
         </p:txBody>
@@ -6695,6 +6799,287 @@
       </p:sp>
       <p:pic>
         <p:nvPicPr>
+          <p:cNvPr id="5" name="Picture 4" descr="fig16_ips_time_and_memory.png"/>
+          <p:cNvPicPr>
+            <a:picLocks noChangeAspect="1"/>
+          </p:cNvPicPr>
+          <p:nvPr/>
+        </p:nvPicPr>
+        <p:blipFill>
+          <a:blip r:embed="rId2"/>
+          <a:stretch>
+            <a:fillRect/>
+          </a:stretch>
+        </p:blipFill>
+        <p:spPr>
+          <a:xfrm>
+            <a:off x="2604332" y="1581912"/>
+            <a:ext cx="6952855" cy="3172968"/>
+          </a:xfrm>
+          <a:prstGeom prst="rect">
+            <a:avLst/>
+          </a:prstGeom>
+        </p:spPr>
+      </p:pic>
+      <p:sp>
+        <p:nvSpPr>
+          <p:cNvPr id="6" name="TextBox 5"/>
+          <p:cNvSpPr txBox="1"/>
+          <p:nvPr/>
+        </p:nvSpPr>
+        <p:spPr>
+          <a:xfrm>
+            <a:off x="502920" y="4864608"/>
+            <a:ext cx="11201400" cy="1856231"/>
+          </a:xfrm>
+          <a:prstGeom prst="rect">
+            <a:avLst/>
+          </a:prstGeom>
+          <a:noFill/>
+        </p:spPr>
+        <p:txBody>
+          <a:bodyPr wrap="square" anchor="t">
+            <a:spAutoFit/>
+          </a:bodyPr>
+          <a:lstStyle/>
+          <a:p>
+            <a:pPr algn="l">
+              <a:lnSpc>
+                <a:spcPct val="112000"/>
+              </a:lnSpc>
+              <a:spcAft>
+                <a:spcPts val="700"/>
+              </a:spcAft>
+            </a:pPr>
+            <a:r>
+              <a:rPr sz="1300" b="0" i="0">
+                <a:solidFill>
+                  <a:srgbClr val="1A1A1A"/>
+                </a:solidFill>
+                <a:latin typeface="Times New Roman"/>
+                <a:ea typeface="Times New Roman"/>
+                <a:cs typeface="Times New Roman"/>
+              </a:rPr>
+              <a:t>–  Baseline 520 WAP: 1.207 ms/fingerprint, CSDL vân tay 79.1 MB.</a:t>
+            </a:r>
+          </a:p>
+          <a:p>
+            <a:pPr algn="l">
+              <a:lnSpc>
+                <a:spcPct val="112000"/>
+              </a:lnSpc>
+              <a:spcAft>
+                <a:spcPts val="700"/>
+              </a:spcAft>
+            </a:pPr>
+            <a:r>
+              <a:rPr sz="1300" b="0" i="0">
+                <a:solidFill>
+                  <a:srgbClr val="1A1A1A"/>
+                </a:solidFill>
+                <a:latin typeface="Times New Roman"/>
+                <a:ea typeface="Times New Roman"/>
+                <a:cs typeface="Times New Roman"/>
+              </a:rPr>
+              <a:t>–  control_top_support__n200 (200 WAP): 0.491 ms/fp (2.5× nhanh hơn), 38% bộ nhớ, và joint accuracy 88.48% (+0.72 pp).</a:t>
+            </a:r>
+          </a:p>
+          <a:p>
+            <a:pPr algn="l">
+              <a:lnSpc>
+                <a:spcPct val="112000"/>
+              </a:lnSpc>
+              <a:spcAft>
+                <a:spcPts val="700"/>
+              </a:spcAft>
+            </a:pPr>
+            <a:r>
+              <a:rPr sz="1300" b="0" i="0">
+                <a:solidFill>
+                  <a:srgbClr val="1A1A1A"/>
+                </a:solidFill>
+                <a:latin typeface="Times New Roman"/>
+                <a:ea typeface="Times New Roman"/>
+                <a:cs typeface="Times New Roman"/>
+              </a:rPr>
+              <a:t>–  HUIM tốt nhất (91 WAP): 5.4× nhanh hơn, 18% bộ nhớ, nhưng accuracy 71.56%.</a:t>
+            </a:r>
+          </a:p>
+          <a:p>
+            <a:pPr algn="l">
+              <a:lnSpc>
+                <a:spcPct val="112000"/>
+              </a:lnSpc>
+              <a:spcAft>
+                <a:spcPts val="700"/>
+              </a:spcAft>
+            </a:pPr>
+            <a:r>
+              <a:rPr sz="1300" b="0" i="0">
+                <a:solidFill>
+                  <a:srgbClr val="1A1A1A"/>
+                </a:solidFill>
+                <a:latin typeface="Times New Roman"/>
+                <a:ea typeface="Times New Roman"/>
+                <a:cs typeface="Times New Roman"/>
+              </a:rPr>
+              <a:t>–  Đo một lõi, lặp lại lấy trung vị; bộ nhớ CSDL tính chính xác (dòng × cột × kích thước phần tử), không ước lượng.</a:t>
+            </a:r>
+          </a:p>
+        </p:txBody>
+      </p:sp>
+    </p:spTree>
+  </p:cSld>
+  <p:clrMapOvr>
+    <a:masterClrMapping/>
+  </p:clrMapOvr>
+</p:sld>
+</file>
+
+<file path=ppt/slides/slide15.xml><?xml version="1.0" encoding="utf-8"?>
+<p:sld xmlns:a="http://schemas.openxmlformats.org/drawingml/2006/main" xmlns:p="http://schemas.openxmlformats.org/presentationml/2006/main" xmlns:r="http://schemas.openxmlformats.org/officeDocument/2006/relationships">
+  <p:cSld>
+    <p:spTree>
+      <p:nvGrpSpPr>
+        <p:cNvPr id="1" name=""/>
+        <p:cNvGrpSpPr/>
+        <p:nvPr/>
+      </p:nvGrpSpPr>
+      <p:grpSpPr/>
+      <p:sp>
+        <p:nvSpPr>
+          <p:cNvPr id="2" name="TextBox 1"/>
+          <p:cNvSpPr txBox="1"/>
+          <p:nvPr/>
+        </p:nvSpPr>
+        <p:spPr>
+          <a:xfrm>
+            <a:off x="502920" y="292608"/>
+            <a:ext cx="11155680" cy="822960"/>
+          </a:xfrm>
+          <a:prstGeom prst="rect">
+            <a:avLst/>
+          </a:prstGeom>
+          <a:noFill/>
+        </p:spPr>
+        <p:txBody>
+          <a:bodyPr wrap="square" anchor="t">
+            <a:spAutoFit/>
+          </a:bodyPr>
+          <a:lstStyle/>
+          <a:p>
+            <a:pPr algn="l">
+              <a:lnSpc>
+                <a:spcPct val="112000"/>
+              </a:lnSpc>
+              <a:spcAft>
+                <a:spcPts val="700"/>
+              </a:spcAft>
+            </a:pPr>
+            <a:r>
+              <a:rPr sz="2600" b="1" i="0">
+                <a:solidFill>
+                  <a:srgbClr val="1A1A1A"/>
+                </a:solidFill>
+                <a:latin typeface="Times New Roman"/>
+                <a:ea typeface="Times New Roman"/>
+                <a:cs typeface="Times New Roman"/>
+              </a:rPr>
+              <a:t>Baseline so với HUIM</a:t>
+            </a:r>
+          </a:p>
+        </p:txBody>
+      </p:sp>
+      <p:sp>
+        <p:nvSpPr>
+          <p:cNvPr id="3" name="TextBox 2"/>
+          <p:cNvSpPr txBox="1"/>
+          <p:nvPr/>
+        </p:nvSpPr>
+        <p:spPr>
+          <a:xfrm>
+            <a:off x="502920" y="1024128"/>
+            <a:ext cx="11155680" cy="384048"/>
+          </a:xfrm>
+          <a:prstGeom prst="rect">
+            <a:avLst/>
+          </a:prstGeom>
+          <a:noFill/>
+        </p:spPr>
+        <p:txBody>
+          <a:bodyPr wrap="square" anchor="t">
+            <a:spAutoFit/>
+          </a:bodyPr>
+          <a:lstStyle/>
+          <a:p>
+            <a:pPr algn="l">
+              <a:lnSpc>
+                <a:spcPct val="112000"/>
+              </a:lnSpc>
+              <a:spcAft>
+                <a:spcPts val="700"/>
+              </a:spcAft>
+            </a:pPr>
+            <a:r>
+              <a:rPr sz="1500" b="0" i="0">
+                <a:solidFill>
+                  <a:srgbClr val="6E6E6E"/>
+                </a:solidFill>
+                <a:latin typeface="Times New Roman"/>
+                <a:ea typeface="Times New Roman"/>
+                <a:cs typeface="Times New Roman"/>
+              </a:rPr>
+              <a:t>Building / Floor / Joint accuracy</a:t>
+            </a:r>
+          </a:p>
+        </p:txBody>
+      </p:sp>
+      <p:sp>
+        <p:nvSpPr>
+          <p:cNvPr id="4" name="Rectangle 3"/>
+          <p:cNvSpPr/>
+          <p:nvPr/>
+        </p:nvSpPr>
+        <p:spPr>
+          <a:xfrm>
+            <a:off x="502920" y="1426464"/>
+            <a:ext cx="11155680" cy="9525"/>
+          </a:xfrm>
+          <a:prstGeom prst="rect">
+            <a:avLst/>
+          </a:prstGeom>
+          <a:solidFill>
+            <a:srgbClr val="C8C8C8"/>
+          </a:solidFill>
+          <a:ln>
+            <a:noFill/>
+          </a:ln>
+          <a:effectLst/>
+        </p:spPr>
+        <p:style>
+          <a:lnRef idx="1">
+            <a:schemeClr val="accent1"/>
+          </a:lnRef>
+          <a:fillRef idx="3">
+            <a:schemeClr val="accent1"/>
+          </a:fillRef>
+          <a:effectRef idx="2">
+            <a:schemeClr val="accent1"/>
+          </a:effectRef>
+          <a:fontRef idx="minor">
+            <a:schemeClr val="lt1"/>
+          </a:fontRef>
+        </p:style>
+        <p:txBody>
+          <a:bodyPr rtlCol="0" anchor="ctr"/>
+          <a:lstStyle/>
+          <a:p>
+            <a:pPr algn="ctr"/>
+          </a:p>
+        </p:txBody>
+      </p:sp>
+      <p:pic>
+        <p:nvPicPr>
           <p:cNvPr id="5" name="Picture 4" descr="fig10_baseline_vs_huim_accuracies.png"/>
           <p:cNvPicPr>
             <a:picLocks noChangeAspect="1"/>
@@ -6709,8 +7094,8 @@
         </p:blipFill>
         <p:spPr>
           <a:xfrm>
-            <a:off x="3305105" y="1627632"/>
-            <a:ext cx="5551309" cy="3218687"/>
+            <a:off x="3341690" y="1627632"/>
+            <a:ext cx="5478139" cy="3218687"/>
           </a:xfrm>
           <a:prstGeom prst="rect">
             <a:avLst/>
@@ -6790,7 +7175,7 @@
 </p:sld>
 </file>
 
-<file path=ppt/slides/slide15.xml><?xml version="1.0" encoding="utf-8"?>
+<file path=ppt/slides/slide16.xml><?xml version="1.0" encoding="utf-8"?>
 <p:sld xmlns:a="http://schemas.openxmlformats.org/drawingml/2006/main" xmlns:p="http://schemas.openxmlformats.org/presentationml/2006/main" xmlns:r="http://schemas.openxmlformats.org/officeDocument/2006/relationships">
   <p:cSld>
     <p:spTree>
@@ -8333,7 +8718,7 @@
 </p:sld>
 </file>
 
-<file path=ppt/slides/slide16.xml><?xml version="1.0" encoding="utf-8"?>
+<file path=ppt/slides/slide17.xml><?xml version="1.0" encoding="utf-8"?>
 <p:sld xmlns:a="http://schemas.openxmlformats.org/drawingml/2006/main" xmlns:p="http://schemas.openxmlformats.org/presentationml/2006/main" xmlns:r="http://schemas.openxmlformats.org/officeDocument/2006/relationships">
   <p:cSld>
     <p:spTree>
@@ -8614,7 +8999,7 @@
 </p:sld>
 </file>
 
-<file path=ppt/slides/slide17.xml><?xml version="1.0" encoding="utf-8"?>
+<file path=ppt/slides/slide18.xml><?xml version="1.0" encoding="utf-8"?>
 <p:sld xmlns:a="http://schemas.openxmlformats.org/drawingml/2006/main" xmlns:p="http://schemas.openxmlformats.org/presentationml/2006/main" xmlns:r="http://schemas.openxmlformats.org/officeDocument/2006/relationships">
   <p:cSld>
     <p:spTree>
@@ -9002,7 +9387,7 @@
 </p:sld>
 </file>
 
-<file path=ppt/slides/slide18.xml><?xml version="1.0" encoding="utf-8"?>
+<file path=ppt/slides/slide19.xml><?xml version="1.0" encoding="utf-8"?>
 <p:sld xmlns:a="http://schemas.openxmlformats.org/drawingml/2006/main" xmlns:p="http://schemas.openxmlformats.org/presentationml/2006/main" xmlns:r="http://schemas.openxmlformats.org/officeDocument/2006/relationships">
   <p:cSld>
     <p:spTree>
@@ -9443,305 +9828,6 @@
                 <a:cs typeface="Times New Roman"/>
               </a:rPr>
               <a:t>–  KHÔNG phải bộ chọn đặc trưng CÓ GIÁM SÁT — không có mục tiêu phân loại trong định nghĩa.</a:t>
-            </a:r>
-          </a:p>
-        </p:txBody>
-      </p:sp>
-    </p:spTree>
-  </p:cSld>
-  <p:clrMapOvr>
-    <a:masterClrMapping/>
-  </p:clrMapOvr>
-</p:sld>
-</file>
-
-<file path=ppt/slides/slide19.xml><?xml version="1.0" encoding="utf-8"?>
-<p:sld xmlns:a="http://schemas.openxmlformats.org/drawingml/2006/main" xmlns:p="http://schemas.openxmlformats.org/presentationml/2006/main" xmlns:r="http://schemas.openxmlformats.org/officeDocument/2006/relationships">
-  <p:cSld>
-    <p:spTree>
-      <p:nvGrpSpPr>
-        <p:cNvPr id="1" name=""/>
-        <p:cNvGrpSpPr/>
-        <p:nvPr/>
-      </p:nvGrpSpPr>
-      <p:grpSpPr/>
-      <p:sp>
-        <p:nvSpPr>
-          <p:cNvPr id="2" name="TextBox 1"/>
-          <p:cNvSpPr txBox="1"/>
-          <p:nvPr/>
-        </p:nvSpPr>
-        <p:spPr>
-          <a:xfrm>
-            <a:off x="502920" y="292608"/>
-            <a:ext cx="11155680" cy="822960"/>
-          </a:xfrm>
-          <a:prstGeom prst="rect">
-            <a:avLst/>
-          </a:prstGeom>
-          <a:noFill/>
-        </p:spPr>
-        <p:txBody>
-          <a:bodyPr wrap="square" anchor="t">
-            <a:spAutoFit/>
-          </a:bodyPr>
-          <a:lstStyle/>
-          <a:p>
-            <a:pPr algn="l">
-              <a:lnSpc>
-                <a:spcPct val="112000"/>
-              </a:lnSpc>
-              <a:spcAft>
-                <a:spcPts val="700"/>
-              </a:spcAft>
-            </a:pPr>
-            <a:r>
-              <a:rPr sz="2600" b="1" i="0">
-                <a:solidFill>
-                  <a:srgbClr val="1A1A1A"/>
-                </a:solidFill>
-                <a:latin typeface="Times New Roman"/>
-                <a:ea typeface="Times New Roman"/>
-                <a:cs typeface="Times New Roman"/>
-              </a:rPr>
-              <a:t>Kết luận</a:t>
-            </a:r>
-          </a:p>
-        </p:txBody>
-      </p:sp>
-      <p:sp>
-        <p:nvSpPr>
-          <p:cNvPr id="3" name="Rectangle 2"/>
-          <p:cNvSpPr/>
-          <p:nvPr/>
-        </p:nvSpPr>
-        <p:spPr>
-          <a:xfrm>
-            <a:off x="502920" y="969264"/>
-            <a:ext cx="11155680" cy="9525"/>
-          </a:xfrm>
-          <a:prstGeom prst="rect">
-            <a:avLst/>
-          </a:prstGeom>
-          <a:solidFill>
-            <a:srgbClr val="C8C8C8"/>
-          </a:solidFill>
-          <a:ln>
-            <a:noFill/>
-          </a:ln>
-          <a:effectLst/>
-        </p:spPr>
-        <p:style>
-          <a:lnRef idx="1">
-            <a:schemeClr val="accent1"/>
-          </a:lnRef>
-          <a:fillRef idx="3">
-            <a:schemeClr val="accent1"/>
-          </a:fillRef>
-          <a:effectRef idx="2">
-            <a:schemeClr val="accent1"/>
-          </a:effectRef>
-          <a:fontRef idx="minor">
-            <a:schemeClr val="lt1"/>
-          </a:fontRef>
-        </p:style>
-        <p:txBody>
-          <a:bodyPr rtlCol="0" anchor="ctr"/>
-          <a:lstStyle/>
-          <a:p>
-            <a:pPr algn="ctr"/>
-          </a:p>
-        </p:txBody>
-      </p:sp>
-      <p:sp>
-        <p:nvSpPr>
-          <p:cNvPr id="4" name="TextBox 3"/>
-          <p:cNvSpPr txBox="1"/>
-          <p:nvPr/>
-        </p:nvSpPr>
-        <p:spPr>
-          <a:xfrm>
-            <a:off x="640080" y="1261872"/>
-            <a:ext cx="10972800" cy="3931920"/>
-          </a:xfrm>
-          <a:prstGeom prst="rect">
-            <a:avLst/>
-          </a:prstGeom>
-          <a:noFill/>
-        </p:spPr>
-        <p:txBody>
-          <a:bodyPr wrap="square" anchor="t">
-            <a:spAutoFit/>
-          </a:bodyPr>
-          <a:lstStyle/>
-          <a:p>
-            <a:pPr algn="l">
-              <a:lnSpc>
-                <a:spcPct val="112000"/>
-              </a:lnSpc>
-              <a:spcAft>
-                <a:spcPts val="700"/>
-              </a:spcAft>
-            </a:pPr>
-            <a:r>
-              <a:rPr sz="1300" b="0" i="0">
-                <a:solidFill>
-                  <a:srgbClr val="1A1A1A"/>
-                </a:solidFill>
-                <a:latin typeface="Times New Roman"/>
-                <a:ea typeface="Times New Roman"/>
-                <a:cs typeface="Times New Roman"/>
-              </a:rPr>
-              <a:t>–  HUIM áp dụng được về mặt kỹ thuật: 19,861 utility transaction, EFIM chạy và cho kết quả; nhưng 'hợp lý' là hợp lý CỦA ĐỊNH NGHĨA utility, không phải tính chất của bộ dữ liệu.</a:t>
-            </a:r>
-          </a:p>
-          <a:p>
-            <a:pPr algn="l">
-              <a:lnSpc>
-                <a:spcPct val="112000"/>
-              </a:lnSpc>
-              <a:spcAft>
-                <a:spcPts val="700"/>
-              </a:spcAft>
-            </a:pPr>
-            <a:r>
-              <a:rPr sz="1300" b="0" i="0">
-                <a:solidFill>
-                  <a:srgbClr val="1A1A1A"/>
-                </a:solidFill>
-                <a:latin typeface="Times New Roman"/>
-                <a:ea typeface="Times New Roman"/>
-                <a:cs typeface="Times New Roman"/>
-              </a:rPr>
-              <a:t>–  Discriminative utility (Model B) cho đường cong ngưỡng mượt hơn và chọn tập AP khác Model A (Jaccard 0.528 cho cặp đầu tiên).</a:t>
-            </a:r>
-          </a:p>
-          <a:p>
-            <a:pPr algn="l">
-              <a:lnSpc>
-                <a:spcPct val="112000"/>
-              </a:lnSpc>
-              <a:spcAft>
-                <a:spcPts val="700"/>
-              </a:spcAft>
-            </a:pPr>
-            <a:r>
-              <a:rPr sz="1300" b="0" i="0">
-                <a:solidFill>
-                  <a:srgbClr val="1A1A1A"/>
-                </a:solidFill>
-                <a:latin typeface="Times New Roman"/>
-                <a:ea typeface="Times New Roman"/>
-                <a:cs typeface="Times New Roman"/>
-              </a:rPr>
-              <a:t>–  Giảm chiều: không cấu hình HUIM nào đạt baseline 87.76% (520 WAP); trade-off có thật nhưng không thuận lợi.</a:t>
-            </a:r>
-          </a:p>
-          <a:p>
-            <a:pPr algn="l">
-              <a:lnSpc>
-                <a:spcPct val="112000"/>
-              </a:lnSpc>
-              <a:spcAft>
-                <a:spcPts val="700"/>
-              </a:spcAft>
-            </a:pPr>
-            <a:r>
-              <a:rPr sz="1300" b="0" i="0">
-                <a:solidFill>
-                  <a:srgbClr val="1A1A1A"/>
-                </a:solidFill>
-                <a:latin typeface="Times New Roman"/>
-                <a:ea typeface="Times New Roman"/>
-                <a:cs typeface="Times New Roman"/>
-              </a:rPr>
-              <a:t>–  CƠ CHẾ: tập AP lớn nhất HUIM tạo ra là 91 WAP. Ở ngân sách đó, MỌI phương pháp đều chỉ đạt tối đa 74.44%, trong khi cần 200 WAP mới chạm baseline — ngay cả một xếp hạng hoàn hảo cũng không thể lấp khoảng cách từ bên trong trần đó.</a:t>
-            </a:r>
-          </a:p>
-          <a:p>
-            <a:pPr algn="l">
-              <a:lnSpc>
-                <a:spcPct val="112000"/>
-              </a:lnSpc>
-              <a:spcAft>
-                <a:spcPts val="700"/>
-              </a:spcAft>
-            </a:pPr>
-            <a:r>
-              <a:rPr sz="1300" b="0" i="0">
-                <a:solidFill>
-                  <a:srgbClr val="1A1A1A"/>
-                </a:solidFill>
-                <a:latin typeface="Times New Roman"/>
-                <a:ea typeface="Times New Roman"/>
-                <a:cs typeface="Times New Roman"/>
-              </a:rPr>
-              <a:t>–  ĐỐI CHỨNG: Model A (signal) vượt ngẫu nhiên 0/8; Model B (discriminative) vượt ngẫu nhiên 5/8; Model C (rare-discr.) vượt ngẫu nhiên 3/8; HUIM tốt nhất vượt top-n theo MI 3/8.</a:t>
-            </a:r>
-          </a:p>
-          <a:p>
-            <a:pPr algn="l">
-              <a:lnSpc>
-                <a:spcPct val="112000"/>
-              </a:lnSpc>
-              <a:spcAft>
-                <a:spcPts val="700"/>
-              </a:spcAft>
-            </a:pPr>
-            <a:r>
-              <a:rPr sz="1300" b="0" i="0">
-                <a:solidFill>
-                  <a:srgbClr val="1A1A1A"/>
-                </a:solidFill>
-                <a:latin typeface="Times New Roman"/>
-                <a:ea typeface="Times New Roman"/>
-                <a:cs typeface="Times New Roman"/>
-              </a:rPr>
-              <a:t>–  Đóng góp: khảo sát khả năng thích nghi HUIM cho bài toán chọn nhóm AP — có đối chứng, có thể cho kết quả âm, không tuyên bố novelty.</a:t>
-            </a:r>
-          </a:p>
-        </p:txBody>
-      </p:sp>
-      <p:sp>
-        <p:nvSpPr>
-          <p:cNvPr id="5" name="TextBox 4"/>
-          <p:cNvSpPr txBox="1"/>
-          <p:nvPr/>
-        </p:nvSpPr>
-        <p:spPr>
-          <a:xfrm>
-            <a:off x="640080" y="5989320"/>
-            <a:ext cx="10972800" cy="411480"/>
-          </a:xfrm>
-          <a:prstGeom prst="rect">
-            <a:avLst/>
-          </a:prstGeom>
-          <a:noFill/>
-        </p:spPr>
-        <p:txBody>
-          <a:bodyPr wrap="square" anchor="t">
-            <a:spAutoFit/>
-          </a:bodyPr>
-          <a:lstStyle/>
-          <a:p>
-            <a:pPr algn="l">
-              <a:lnSpc>
-                <a:spcPct val="112000"/>
-              </a:lnSpc>
-              <a:spcAft>
-                <a:spcPts val="700"/>
-              </a:spcAft>
-            </a:pPr>
-            <a:r>
-              <a:rPr sz="1050" b="0" i="0">
-                <a:solidFill>
-                  <a:srgbClr val="6E6E6E"/>
-                </a:solidFill>
-                <a:latin typeface="Times New Roman"/>
-                <a:ea typeface="Times New Roman"/>
-                <a:cs typeface="Times New Roman"/>
-              </a:rPr>
-              <a:t>Mọi con số trong bài đọc trực tiếp từ results/ và figures/; script sinh slide không chứa giá trị thực nghiệm nào.</a:t>
             </a:r>
           </a:p>
         </p:txBody>
@@ -10057,6 +10143,305 @@
 </file>
 
 <file path=ppt/slides/slide20.xml><?xml version="1.0" encoding="utf-8"?>
+<p:sld xmlns:a="http://schemas.openxmlformats.org/drawingml/2006/main" xmlns:p="http://schemas.openxmlformats.org/presentationml/2006/main" xmlns:r="http://schemas.openxmlformats.org/officeDocument/2006/relationships">
+  <p:cSld>
+    <p:spTree>
+      <p:nvGrpSpPr>
+        <p:cNvPr id="1" name=""/>
+        <p:cNvGrpSpPr/>
+        <p:nvPr/>
+      </p:nvGrpSpPr>
+      <p:grpSpPr/>
+      <p:sp>
+        <p:nvSpPr>
+          <p:cNvPr id="2" name="TextBox 1"/>
+          <p:cNvSpPr txBox="1"/>
+          <p:nvPr/>
+        </p:nvSpPr>
+        <p:spPr>
+          <a:xfrm>
+            <a:off x="502920" y="292608"/>
+            <a:ext cx="11155680" cy="822960"/>
+          </a:xfrm>
+          <a:prstGeom prst="rect">
+            <a:avLst/>
+          </a:prstGeom>
+          <a:noFill/>
+        </p:spPr>
+        <p:txBody>
+          <a:bodyPr wrap="square" anchor="t">
+            <a:spAutoFit/>
+          </a:bodyPr>
+          <a:lstStyle/>
+          <a:p>
+            <a:pPr algn="l">
+              <a:lnSpc>
+                <a:spcPct val="112000"/>
+              </a:lnSpc>
+              <a:spcAft>
+                <a:spcPts val="700"/>
+              </a:spcAft>
+            </a:pPr>
+            <a:r>
+              <a:rPr sz="2600" b="1" i="0">
+                <a:solidFill>
+                  <a:srgbClr val="1A1A1A"/>
+                </a:solidFill>
+                <a:latin typeface="Times New Roman"/>
+                <a:ea typeface="Times New Roman"/>
+                <a:cs typeface="Times New Roman"/>
+              </a:rPr>
+              <a:t>Kết luận</a:t>
+            </a:r>
+          </a:p>
+        </p:txBody>
+      </p:sp>
+      <p:sp>
+        <p:nvSpPr>
+          <p:cNvPr id="3" name="Rectangle 2"/>
+          <p:cNvSpPr/>
+          <p:nvPr/>
+        </p:nvSpPr>
+        <p:spPr>
+          <a:xfrm>
+            <a:off x="502920" y="969264"/>
+            <a:ext cx="11155680" cy="9525"/>
+          </a:xfrm>
+          <a:prstGeom prst="rect">
+            <a:avLst/>
+          </a:prstGeom>
+          <a:solidFill>
+            <a:srgbClr val="C8C8C8"/>
+          </a:solidFill>
+          <a:ln>
+            <a:noFill/>
+          </a:ln>
+          <a:effectLst/>
+        </p:spPr>
+        <p:style>
+          <a:lnRef idx="1">
+            <a:schemeClr val="accent1"/>
+          </a:lnRef>
+          <a:fillRef idx="3">
+            <a:schemeClr val="accent1"/>
+          </a:fillRef>
+          <a:effectRef idx="2">
+            <a:schemeClr val="accent1"/>
+          </a:effectRef>
+          <a:fontRef idx="minor">
+            <a:schemeClr val="lt1"/>
+          </a:fontRef>
+        </p:style>
+        <p:txBody>
+          <a:bodyPr rtlCol="0" anchor="ctr"/>
+          <a:lstStyle/>
+          <a:p>
+            <a:pPr algn="ctr"/>
+          </a:p>
+        </p:txBody>
+      </p:sp>
+      <p:sp>
+        <p:nvSpPr>
+          <p:cNvPr id="4" name="TextBox 3"/>
+          <p:cNvSpPr txBox="1"/>
+          <p:nvPr/>
+        </p:nvSpPr>
+        <p:spPr>
+          <a:xfrm>
+            <a:off x="640080" y="1261872"/>
+            <a:ext cx="10972800" cy="3931920"/>
+          </a:xfrm>
+          <a:prstGeom prst="rect">
+            <a:avLst/>
+          </a:prstGeom>
+          <a:noFill/>
+        </p:spPr>
+        <p:txBody>
+          <a:bodyPr wrap="square" anchor="t">
+            <a:spAutoFit/>
+          </a:bodyPr>
+          <a:lstStyle/>
+          <a:p>
+            <a:pPr algn="l">
+              <a:lnSpc>
+                <a:spcPct val="112000"/>
+              </a:lnSpc>
+              <a:spcAft>
+                <a:spcPts val="700"/>
+              </a:spcAft>
+            </a:pPr>
+            <a:r>
+              <a:rPr sz="1300" b="0" i="0">
+                <a:solidFill>
+                  <a:srgbClr val="1A1A1A"/>
+                </a:solidFill>
+                <a:latin typeface="Times New Roman"/>
+                <a:ea typeface="Times New Roman"/>
+                <a:cs typeface="Times New Roman"/>
+              </a:rPr>
+              <a:t>–  HUIM áp dụng được về mặt kỹ thuật: 19,861 utility transaction, EFIM chạy và cho kết quả; nhưng 'hợp lý' là hợp lý CỦA ĐỊNH NGHĨA utility, không phải tính chất của bộ dữ liệu.</a:t>
+            </a:r>
+          </a:p>
+          <a:p>
+            <a:pPr algn="l">
+              <a:lnSpc>
+                <a:spcPct val="112000"/>
+              </a:lnSpc>
+              <a:spcAft>
+                <a:spcPts val="700"/>
+              </a:spcAft>
+            </a:pPr>
+            <a:r>
+              <a:rPr sz="1300" b="0" i="0">
+                <a:solidFill>
+                  <a:srgbClr val="1A1A1A"/>
+                </a:solidFill>
+                <a:latin typeface="Times New Roman"/>
+                <a:ea typeface="Times New Roman"/>
+                <a:cs typeface="Times New Roman"/>
+              </a:rPr>
+              <a:t>–  Discriminative utility (Model B) cho đường cong ngưỡng mượt hơn và chọn tập AP khác Model A (Jaccard 0.528 cho cặp đầu tiên).</a:t>
+            </a:r>
+          </a:p>
+          <a:p>
+            <a:pPr algn="l">
+              <a:lnSpc>
+                <a:spcPct val="112000"/>
+              </a:lnSpc>
+              <a:spcAft>
+                <a:spcPts val="700"/>
+              </a:spcAft>
+            </a:pPr>
+            <a:r>
+              <a:rPr sz="1300" b="0" i="0">
+                <a:solidFill>
+                  <a:srgbClr val="1A1A1A"/>
+                </a:solidFill>
+                <a:latin typeface="Times New Roman"/>
+                <a:ea typeface="Times New Roman"/>
+                <a:cs typeface="Times New Roman"/>
+              </a:rPr>
+              <a:t>–  Giảm chiều: không cấu hình HUIM nào đạt baseline 87.76% (520 WAP); trade-off có thật nhưng không thuận lợi.</a:t>
+            </a:r>
+          </a:p>
+          <a:p>
+            <a:pPr algn="l">
+              <a:lnSpc>
+                <a:spcPct val="112000"/>
+              </a:lnSpc>
+              <a:spcAft>
+                <a:spcPts val="700"/>
+              </a:spcAft>
+            </a:pPr>
+            <a:r>
+              <a:rPr sz="1300" b="0" i="0">
+                <a:solidFill>
+                  <a:srgbClr val="1A1A1A"/>
+                </a:solidFill>
+                <a:latin typeface="Times New Roman"/>
+                <a:ea typeface="Times New Roman"/>
+                <a:cs typeface="Times New Roman"/>
+              </a:rPr>
+              <a:t>–  CƠ CHẾ: tập AP lớn nhất HUIM tạo ra là 91 WAP. Ở ngân sách đó, MỌI phương pháp đều chỉ đạt tối đa 74.44%, trong khi cần 200 WAP mới chạm baseline — ngay cả một xếp hạng hoàn hảo cũng không thể lấp khoảng cách từ bên trong trần đó.</a:t>
+            </a:r>
+          </a:p>
+          <a:p>
+            <a:pPr algn="l">
+              <a:lnSpc>
+                <a:spcPct val="112000"/>
+              </a:lnSpc>
+              <a:spcAft>
+                <a:spcPts val="700"/>
+              </a:spcAft>
+            </a:pPr>
+            <a:r>
+              <a:rPr sz="1300" b="0" i="0">
+                <a:solidFill>
+                  <a:srgbClr val="1A1A1A"/>
+                </a:solidFill>
+                <a:latin typeface="Times New Roman"/>
+                <a:ea typeface="Times New Roman"/>
+                <a:cs typeface="Times New Roman"/>
+              </a:rPr>
+              <a:t>–  ĐỐI CHỨNG: Model A (signal) vượt ngẫu nhiên 0/8; Model B (discriminative) vượt ngẫu nhiên 5/8; Model C (rare-discr.) vượt ngẫu nhiên 3/8; HUIM tốt nhất vượt top-n theo MI 3/8.</a:t>
+            </a:r>
+          </a:p>
+          <a:p>
+            <a:pPr algn="l">
+              <a:lnSpc>
+                <a:spcPct val="112000"/>
+              </a:lnSpc>
+              <a:spcAft>
+                <a:spcPts val="700"/>
+              </a:spcAft>
+            </a:pPr>
+            <a:r>
+              <a:rPr sz="1300" b="0" i="0">
+                <a:solidFill>
+                  <a:srgbClr val="1A1A1A"/>
+                </a:solidFill>
+                <a:latin typeface="Times New Roman"/>
+                <a:ea typeface="Times New Roman"/>
+                <a:cs typeface="Times New Roman"/>
+              </a:rPr>
+              <a:t>–  Đóng góp: khảo sát khả năng thích nghi HUIM cho bài toán chọn nhóm AP — có đối chứng, có thể cho kết quả âm, không tuyên bố novelty.</a:t>
+            </a:r>
+          </a:p>
+        </p:txBody>
+      </p:sp>
+      <p:sp>
+        <p:nvSpPr>
+          <p:cNvPr id="5" name="TextBox 4"/>
+          <p:cNvSpPr txBox="1"/>
+          <p:nvPr/>
+        </p:nvSpPr>
+        <p:spPr>
+          <a:xfrm>
+            <a:off x="640080" y="5989320"/>
+            <a:ext cx="10972800" cy="411480"/>
+          </a:xfrm>
+          <a:prstGeom prst="rect">
+            <a:avLst/>
+          </a:prstGeom>
+          <a:noFill/>
+        </p:spPr>
+        <p:txBody>
+          <a:bodyPr wrap="square" anchor="t">
+            <a:spAutoFit/>
+          </a:bodyPr>
+          <a:lstStyle/>
+          <a:p>
+            <a:pPr algn="l">
+              <a:lnSpc>
+                <a:spcPct val="112000"/>
+              </a:lnSpc>
+              <a:spcAft>
+                <a:spcPts val="700"/>
+              </a:spcAft>
+            </a:pPr>
+            <a:r>
+              <a:rPr sz="1050" b="0" i="0">
+                <a:solidFill>
+                  <a:srgbClr val="6E6E6E"/>
+                </a:solidFill>
+                <a:latin typeface="Times New Roman"/>
+                <a:ea typeface="Times New Roman"/>
+                <a:cs typeface="Times New Roman"/>
+              </a:rPr>
+              <a:t>Mọi con số trong bài đọc trực tiếp từ results/ và figures/; script sinh slide không chứa giá trị thực nghiệm nào.</a:t>
+            </a:r>
+          </a:p>
+        </p:txBody>
+      </p:sp>
+    </p:spTree>
+  </p:cSld>
+  <p:clrMapOvr>
+    <a:masterClrMapping/>
+  </p:clrMapOvr>
+</p:sld>
+</file>
+
+<file path=ppt/slides/slide21.xml><?xml version="1.0" encoding="utf-8"?>
 <p:sld xmlns:a="http://schemas.openxmlformats.org/drawingml/2006/main" xmlns:p="http://schemas.openxmlformats.org/presentationml/2006/main" xmlns:r="http://schemas.openxmlformats.org/officeDocument/2006/relationships">
   <p:cSld>
     <p:spTree>

</xml_diff>